<commit_message>
Atualização de pastas artes gráficas
DeCS 2026
Slides Capacitação 2026
</commit_message>
<xml_diff>
--- a/slides/Capacitação 2026/slides/slide-en.pptx
+++ b/slides/Capacitação 2026/slides/slide-en.pptx
@@ -7,8 +7,6 @@
   <p:sldIdLst>
     <p:sldId id="263" r:id="rId5"/>
     <p:sldId id="275" r:id="rId6"/>
-    <p:sldId id="272" r:id="rId7"/>
-    <p:sldId id="276" r:id="rId8"/>
   </p:sldIdLst>
   <p:sldSz cx="12192000" cy="6858000"/>
   <p:notesSz cx="6858000" cy="9144000"/>
@@ -1502,7 +1500,7 @@
           <a:p>
             <a:fld id="{B849A380-3B9F-47C1-AA12-BD39D524A02F}" type="datetimeFigureOut">
               <a:rPr lang="pt-BR" smtClean="0"/>
-              <a:t>12/03/2025</a:t>
+              <a:t>24/02/2026</a:t>
             </a:fld>
             <a:endParaRPr lang="pt-BR"/>
           </a:p>
@@ -1700,7 +1698,7 @@
           <a:p>
             <a:fld id="{B849A380-3B9F-47C1-AA12-BD39D524A02F}" type="datetimeFigureOut">
               <a:rPr lang="pt-BR" smtClean="0"/>
-              <a:t>12/03/2025</a:t>
+              <a:t>24/02/2026</a:t>
             </a:fld>
             <a:endParaRPr lang="pt-BR"/>
           </a:p>
@@ -1908,7 +1906,7 @@
           <a:p>
             <a:fld id="{B849A380-3B9F-47C1-AA12-BD39D524A02F}" type="datetimeFigureOut">
               <a:rPr lang="pt-BR" smtClean="0"/>
-              <a:t>12/03/2025</a:t>
+              <a:t>24/02/2026</a:t>
             </a:fld>
             <a:endParaRPr lang="pt-BR"/>
           </a:p>
@@ -2106,7 +2104,7 @@
           <a:p>
             <a:fld id="{B849A380-3B9F-47C1-AA12-BD39D524A02F}" type="datetimeFigureOut">
               <a:rPr lang="pt-BR" smtClean="0"/>
-              <a:t>12/03/2025</a:t>
+              <a:t>24/02/2026</a:t>
             </a:fld>
             <a:endParaRPr lang="pt-BR"/>
           </a:p>
@@ -2381,7 +2379,7 @@
           <a:p>
             <a:fld id="{B849A380-3B9F-47C1-AA12-BD39D524A02F}" type="datetimeFigureOut">
               <a:rPr lang="pt-BR" smtClean="0"/>
-              <a:t>12/03/2025</a:t>
+              <a:t>24/02/2026</a:t>
             </a:fld>
             <a:endParaRPr lang="pt-BR"/>
           </a:p>
@@ -2646,7 +2644,7 @@
           <a:p>
             <a:fld id="{B849A380-3B9F-47C1-AA12-BD39D524A02F}" type="datetimeFigureOut">
               <a:rPr lang="pt-BR" smtClean="0"/>
-              <a:t>12/03/2025</a:t>
+              <a:t>24/02/2026</a:t>
             </a:fld>
             <a:endParaRPr lang="pt-BR"/>
           </a:p>
@@ -3058,7 +3056,7 @@
           <a:p>
             <a:fld id="{B849A380-3B9F-47C1-AA12-BD39D524A02F}" type="datetimeFigureOut">
               <a:rPr lang="pt-BR" smtClean="0"/>
-              <a:t>12/03/2025</a:t>
+              <a:t>24/02/2026</a:t>
             </a:fld>
             <a:endParaRPr lang="pt-BR"/>
           </a:p>
@@ -3199,7 +3197,7 @@
           <a:p>
             <a:fld id="{B849A380-3B9F-47C1-AA12-BD39D524A02F}" type="datetimeFigureOut">
               <a:rPr lang="pt-BR" smtClean="0"/>
-              <a:t>12/03/2025</a:t>
+              <a:t>24/02/2026</a:t>
             </a:fld>
             <a:endParaRPr lang="pt-BR"/>
           </a:p>
@@ -3312,7 +3310,7 @@
           <a:p>
             <a:fld id="{B849A380-3B9F-47C1-AA12-BD39D524A02F}" type="datetimeFigureOut">
               <a:rPr lang="pt-BR" smtClean="0"/>
-              <a:t>12/03/2025</a:t>
+              <a:t>24/02/2026</a:t>
             </a:fld>
             <a:endParaRPr lang="pt-BR"/>
           </a:p>
@@ -3623,7 +3621,7 @@
           <a:p>
             <a:fld id="{B849A380-3B9F-47C1-AA12-BD39D524A02F}" type="datetimeFigureOut">
               <a:rPr lang="pt-BR" smtClean="0"/>
-              <a:t>12/03/2025</a:t>
+              <a:t>24/02/2026</a:t>
             </a:fld>
             <a:endParaRPr lang="pt-BR"/>
           </a:p>
@@ -3911,7 +3909,7 @@
           <a:p>
             <a:fld id="{B849A380-3B9F-47C1-AA12-BD39D524A02F}" type="datetimeFigureOut">
               <a:rPr lang="pt-BR" smtClean="0"/>
-              <a:t>12/03/2025</a:t>
+              <a:t>24/02/2026</a:t>
             </a:fld>
             <a:endParaRPr lang="pt-BR"/>
           </a:p>
@@ -4161,7 +4159,7 @@
           <a:p>
             <a:fld id="{B849A380-3B9F-47C1-AA12-BD39D524A02F}" type="datetimeFigureOut">
               <a:rPr lang="pt-BR" smtClean="0"/>
-              <a:t>12/03/2025</a:t>
+              <a:t>24/02/2026</a:t>
             </a:fld>
             <a:endParaRPr lang="pt-BR"/>
           </a:p>
@@ -4594,10 +4592,10 @@
       </p:grpSpPr>
       <p:sp>
         <p:nvSpPr>
-          <p:cNvPr id="14" name="CaixaDeTexto 13">
-            <a:extLst>
-              <a:ext uri="{FF2B5EF4-FFF2-40B4-BE49-F238E27FC236}">
-                <a16:creationId xmlns:a16="http://schemas.microsoft.com/office/drawing/2014/main" id="{4AF9A9BD-510C-45FE-82F4-6B4875D7A388}"/>
+          <p:cNvPr id="21" name="CaixaDeTexto 20">
+            <a:extLst>
+              <a:ext uri="{FF2B5EF4-FFF2-40B4-BE49-F238E27FC236}">
+                <a16:creationId xmlns:a16="http://schemas.microsoft.com/office/drawing/2014/main" id="{9764A249-F0F1-D3E3-4FA7-21AE4372BC1D}"/>
               </a:ext>
             </a:extLst>
           </p:cNvPr>
@@ -4606,8 +4604,8 @@
         </p:nvSpPr>
         <p:spPr>
           <a:xfrm>
-            <a:off x="617295" y="5642842"/>
-            <a:ext cx="1913642" cy="861774"/>
+            <a:off x="544275" y="952715"/>
+            <a:ext cx="8137608" cy="2308324"/>
           </a:xfrm>
           <a:prstGeom prst="rect">
             <a:avLst/>
@@ -4615,67 +4613,50 @@
           <a:noFill/>
         </p:spPr>
         <p:txBody>
-          <a:bodyPr wrap="square" lIns="91440" tIns="45720" rIns="91440" bIns="45720" rtlCol="0" anchor="t">
+          <a:bodyPr wrap="square">
             <a:spAutoFit/>
           </a:bodyPr>
           <a:lstStyle/>
           <a:p>
             <a:r>
-              <a:rPr lang="pt-BR" sz="3600" dirty="0">
+              <a:rPr lang="pt-BR" sz="3600" b="1" i="0" dirty="0">
                 <a:solidFill>
                   <a:schemeClr val="bg1"/>
                 </a:solidFill>
+                <a:effectLst/>
+                <a:latin typeface="-apple-system"/>
               </a:rPr>
-              <a:t>00/mês</a:t>
-            </a:r>
-            <a:endParaRPr lang="en-US" sz="3600" dirty="0" err="1">
+              <a:t>Lançamento do documento técnico sobre</a:t>
+            </a:r>
+          </a:p>
+          <a:p>
+            <a:r>
+              <a:rPr lang="pt-BR" sz="3600" b="1" dirty="0">
+                <a:solidFill>
+                  <a:schemeClr val="bg1"/>
+                </a:solidFill>
+                <a:latin typeface="-apple-system"/>
+                <a:ea typeface="Calibri"/>
+                <a:cs typeface="Calibri"/>
+              </a:rPr>
+              <a:t>Cuidados de Longa Duração: Um conjunto de intervenções para alcançar a cobertura universal de saúde</a:t>
+            </a:r>
+            <a:endParaRPr lang="pt-BR" sz="3600" b="1" dirty="0">
               <a:solidFill>
                 <a:schemeClr val="bg1"/>
               </a:solidFill>
-              <a:cs typeface="Calibri" panose="020F0502020204030204"/>
+              <a:ea typeface="Calibri"/>
+              <a:cs typeface="Calibri"/>
             </a:endParaRPr>
           </a:p>
-          <a:p>
-            <a:pPr algn="ctr"/>
-            <a:r>
-              <a:rPr lang="pt-BR" sz="1400" dirty="0">
-                <a:solidFill>
-                  <a:schemeClr val="bg1"/>
-                </a:solidFill>
-                <a:ea typeface="+mn-lt"/>
-                <a:cs typeface="+mn-lt"/>
-              </a:rPr>
-              <a:t>00 </a:t>
-            </a:r>
-            <a:r>
-              <a:rPr lang="pt-BR" sz="1400" dirty="0" err="1">
-                <a:solidFill>
-                  <a:schemeClr val="bg1"/>
-                </a:solidFill>
-                <a:ea typeface="+mn-lt"/>
-                <a:cs typeface="+mn-lt"/>
-              </a:rPr>
-              <a:t>pm</a:t>
-            </a:r>
-            <a:r>
-              <a:rPr lang="pt-BR" sz="1400" dirty="0">
-                <a:solidFill>
-                  <a:schemeClr val="bg1"/>
-                </a:solidFill>
-                <a:ea typeface="+mn-lt"/>
-                <a:cs typeface="+mn-lt"/>
-              </a:rPr>
-              <a:t> (Brasília, GMT-3)</a:t>
-            </a:r>
-          </a:p>
-        </p:txBody>
-      </p:sp>
-      <p:sp>
-        <p:nvSpPr>
-          <p:cNvPr id="8" name="CaixaDeTexto 7">
-            <a:extLst>
-              <a:ext uri="{FF2B5EF4-FFF2-40B4-BE49-F238E27FC236}">
-                <a16:creationId xmlns:a16="http://schemas.microsoft.com/office/drawing/2014/main" id="{F290792A-350D-4057-9179-0D14067C38FF}"/>
+        </p:txBody>
+      </p:sp>
+      <p:sp>
+        <p:nvSpPr>
+          <p:cNvPr id="23" name="CaixaDeTexto 22">
+            <a:extLst>
+              <a:ext uri="{FF2B5EF4-FFF2-40B4-BE49-F238E27FC236}">
+                <a16:creationId xmlns:a16="http://schemas.microsoft.com/office/drawing/2014/main" id="{953B15D9-65DE-D166-4521-7DB8D10B3B34}"/>
               </a:ext>
             </a:extLst>
           </p:cNvPr>
@@ -4684,8 +4665,8 @@
         </p:nvSpPr>
         <p:spPr>
           <a:xfrm>
-            <a:off x="617294" y="2478826"/>
-            <a:ext cx="5885837" cy="1200329"/>
+            <a:off x="544275" y="325582"/>
+            <a:ext cx="6033324" cy="584775"/>
           </a:xfrm>
           <a:prstGeom prst="rect">
             <a:avLst/>
@@ -4693,181 +4674,42 @@
           <a:noFill/>
         </p:spPr>
         <p:txBody>
-          <a:bodyPr wrap="square" lIns="91440" tIns="45720" rIns="91440" bIns="45720" rtlCol="0" anchor="t">
+          <a:bodyPr wrap="square">
             <a:spAutoFit/>
           </a:bodyPr>
           <a:lstStyle/>
           <a:p>
             <a:r>
-              <a:rPr lang="pt-BR" sz="3600" b="1" i="0" dirty="0" err="1">
+              <a:rPr lang="es-ES" sz="3200" b="1" i="0" dirty="0">
                 <a:solidFill>
-                  <a:schemeClr val="bg1"/>
+                  <a:schemeClr val="accent4">
+                    <a:lumMod val="60000"/>
+                    <a:lumOff val="40000"/>
+                  </a:schemeClr>
                 </a:solidFill>
                 <a:effectLst/>
-                <a:ea typeface="Open Sans" panose="020B0606030504020204" pitchFamily="34" charset="0"/>
-                <a:cs typeface="Open Sans" panose="020B0606030504020204" pitchFamily="34" charset="0"/>
+                <a:latin typeface="-apple-system"/>
               </a:rPr>
-              <a:t>Lorem</a:t>
-            </a:r>
-            <a:r>
-              <a:rPr lang="pt-BR" sz="3600" b="1" i="0" dirty="0">
-                <a:solidFill>
-                  <a:schemeClr val="bg1"/>
-                </a:solidFill>
-                <a:effectLst/>
-                <a:ea typeface="Open Sans" panose="020B0606030504020204" pitchFamily="34" charset="0"/>
-                <a:cs typeface="Open Sans" panose="020B0606030504020204" pitchFamily="34" charset="0"/>
-              </a:rPr>
-              <a:t> ipsum </a:t>
-            </a:r>
-            <a:r>
-              <a:rPr lang="pt-BR" sz="3600" b="1" i="0" dirty="0" err="1">
-                <a:solidFill>
-                  <a:schemeClr val="bg1"/>
-                </a:solidFill>
-                <a:effectLst/>
-                <a:ea typeface="Open Sans" panose="020B0606030504020204" pitchFamily="34" charset="0"/>
-                <a:cs typeface="Open Sans" panose="020B0606030504020204" pitchFamily="34" charset="0"/>
-              </a:rPr>
-              <a:t>dolor</a:t>
-            </a:r>
-            <a:r>
-              <a:rPr lang="pt-BR" sz="3600" b="1" i="0" dirty="0">
-                <a:solidFill>
-                  <a:schemeClr val="bg1"/>
-                </a:solidFill>
-                <a:effectLst/>
-                <a:ea typeface="Open Sans" panose="020B0606030504020204" pitchFamily="34" charset="0"/>
-                <a:cs typeface="Open Sans" panose="020B0606030504020204" pitchFamily="34" charset="0"/>
-              </a:rPr>
-              <a:t> </a:t>
-            </a:r>
-            <a:r>
-              <a:rPr lang="pt-BR" sz="3600" b="1" i="0" dirty="0" err="1">
-                <a:solidFill>
-                  <a:schemeClr val="bg1"/>
-                </a:solidFill>
-                <a:effectLst/>
-                <a:ea typeface="Open Sans" panose="020B0606030504020204" pitchFamily="34" charset="0"/>
-                <a:cs typeface="Open Sans" panose="020B0606030504020204" pitchFamily="34" charset="0"/>
-              </a:rPr>
-              <a:t>sit</a:t>
-            </a:r>
-            <a:r>
-              <a:rPr lang="pt-BR" sz="3600" b="1" i="0" dirty="0">
-                <a:solidFill>
-                  <a:schemeClr val="bg1"/>
-                </a:solidFill>
-                <a:effectLst/>
-                <a:ea typeface="Open Sans" panose="020B0606030504020204" pitchFamily="34" charset="0"/>
-                <a:cs typeface="Open Sans" panose="020B0606030504020204" pitchFamily="34" charset="0"/>
-              </a:rPr>
-              <a:t> </a:t>
-            </a:r>
-            <a:r>
-              <a:rPr lang="pt-BR" sz="3600" b="1" i="0" dirty="0" err="1">
-                <a:solidFill>
-                  <a:schemeClr val="bg1"/>
-                </a:solidFill>
-                <a:effectLst/>
-                <a:ea typeface="Open Sans" panose="020B0606030504020204" pitchFamily="34" charset="0"/>
-                <a:cs typeface="Open Sans" panose="020B0606030504020204" pitchFamily="34" charset="0"/>
-              </a:rPr>
-              <a:t>amet</a:t>
-            </a:r>
-            <a:r>
-              <a:rPr lang="pt-BR" sz="3600" b="1" i="0" dirty="0">
-                <a:solidFill>
-                  <a:schemeClr val="bg1"/>
-                </a:solidFill>
-                <a:effectLst/>
-                <a:ea typeface="Open Sans" panose="020B0606030504020204" pitchFamily="34" charset="0"/>
-                <a:cs typeface="Open Sans" panose="020B0606030504020204" pitchFamily="34" charset="0"/>
-              </a:rPr>
-              <a:t>, </a:t>
-            </a:r>
-            <a:r>
-              <a:rPr lang="pt-BR" sz="3600" b="1" i="0" dirty="0" err="1">
-                <a:solidFill>
-                  <a:schemeClr val="bg1"/>
-                </a:solidFill>
-                <a:effectLst/>
-                <a:ea typeface="Open Sans" panose="020B0606030504020204" pitchFamily="34" charset="0"/>
-                <a:cs typeface="Open Sans" panose="020B0606030504020204" pitchFamily="34" charset="0"/>
-              </a:rPr>
-              <a:t>consectetur</a:t>
-            </a:r>
-            <a:r>
-              <a:rPr lang="pt-BR" sz="3600" b="1" i="0" dirty="0">
-                <a:solidFill>
-                  <a:schemeClr val="bg1"/>
-                </a:solidFill>
-                <a:effectLst/>
-                <a:ea typeface="Open Sans" panose="020B0606030504020204" pitchFamily="34" charset="0"/>
-                <a:cs typeface="Open Sans" panose="020B0606030504020204" pitchFamily="34" charset="0"/>
-              </a:rPr>
-              <a:t> </a:t>
-            </a:r>
-            <a:r>
-              <a:rPr lang="pt-BR" sz="3600" b="1" i="0" dirty="0" err="1">
-                <a:solidFill>
-                  <a:schemeClr val="bg1"/>
-                </a:solidFill>
-                <a:effectLst/>
-                <a:ea typeface="Open Sans" panose="020B0606030504020204" pitchFamily="34" charset="0"/>
-                <a:cs typeface="Open Sans" panose="020B0606030504020204" pitchFamily="34" charset="0"/>
-              </a:rPr>
-              <a:t>adipiscing</a:t>
-            </a:r>
-            <a:r>
-              <a:rPr lang="pt-BR" sz="3600" b="1" i="0" dirty="0">
-                <a:solidFill>
-                  <a:schemeClr val="bg1"/>
-                </a:solidFill>
-                <a:effectLst/>
-                <a:ea typeface="Open Sans" panose="020B0606030504020204" pitchFamily="34" charset="0"/>
-                <a:cs typeface="Open Sans" panose="020B0606030504020204" pitchFamily="34" charset="0"/>
-              </a:rPr>
-              <a:t> </a:t>
-            </a:r>
-            <a:r>
-              <a:rPr lang="pt-BR" sz="3600" b="1" i="0" dirty="0" err="1">
-                <a:solidFill>
-                  <a:schemeClr val="bg1"/>
-                </a:solidFill>
-                <a:effectLst/>
-                <a:ea typeface="Open Sans" panose="020B0606030504020204" pitchFamily="34" charset="0"/>
-                <a:cs typeface="Open Sans" panose="020B0606030504020204" pitchFamily="34" charset="0"/>
-              </a:rPr>
-              <a:t>elit</a:t>
-            </a:r>
-            <a:r>
-              <a:rPr lang="pt-BR" sz="3600" b="1" i="0" dirty="0">
-                <a:solidFill>
-                  <a:schemeClr val="bg1"/>
-                </a:solidFill>
-                <a:effectLst/>
-                <a:ea typeface="Open Sans" panose="020B0606030504020204" pitchFamily="34" charset="0"/>
-                <a:cs typeface="Open Sans" panose="020B0606030504020204" pitchFamily="34" charset="0"/>
-              </a:rPr>
-              <a:t>.</a:t>
-            </a:r>
-            <a:endParaRPr lang="pt-BR" sz="3600" b="1" dirty="0">
+              <a:t>WEBINAR #1</a:t>
+            </a:r>
+            <a:endParaRPr lang="pt-BR" sz="3200" b="1" i="0" dirty="0">
               <a:solidFill>
-                <a:schemeClr val="bg1"/>
+                <a:schemeClr val="accent4">
+                  <a:lumMod val="60000"/>
+                  <a:lumOff val="40000"/>
+                </a:schemeClr>
               </a:solidFill>
-              <a:ea typeface="Open Sans" panose="020B0606030504020204" pitchFamily="34" charset="0"/>
-              <a:cs typeface="Open Sans" panose="020B0606030504020204" pitchFamily="34" charset="0"/>
+              <a:effectLst/>
             </a:endParaRPr>
           </a:p>
         </p:txBody>
       </p:sp>
       <p:pic>
         <p:nvPicPr>
-          <p:cNvPr id="12" name="Imagem 11" descr="Ícone&#10;&#10;Descrição gerada automaticamente">
-            <a:extLst>
-              <a:ext uri="{FF2B5EF4-FFF2-40B4-BE49-F238E27FC236}">
-                <a16:creationId xmlns:a16="http://schemas.microsoft.com/office/drawing/2014/main" id="{3E585B8A-9249-49B7-9F17-CAC6FDBADED9}"/>
+          <p:cNvPr id="6" name="Gráfico 5">
+            <a:extLst>
+              <a:ext uri="{FF2B5EF4-FFF2-40B4-BE49-F238E27FC236}">
+                <a16:creationId xmlns:a16="http://schemas.microsoft.com/office/drawing/2014/main" id="{16F38ADC-34A4-8236-7521-17B550C6FCD7}"/>
               </a:ext>
             </a:extLst>
           </p:cNvPr>
@@ -4879,8 +4721,8 @@
         <p:blipFill>
           <a:blip r:embed="rId3">
             <a:extLst>
-              <a:ext uri="{28A0092B-C50C-407E-A947-70E740481C1C}">
-                <a14:useLocalDpi xmlns:a14="http://schemas.microsoft.com/office/drawing/2010/main" val="0"/>
+              <a:ext uri="{96DAC541-7B7A-43D3-8B79-37D633B846F1}">
+                <asvg:svgBlip xmlns:asvg="http://schemas.microsoft.com/office/drawing/2016/SVG/main" r:embed="rId4"/>
               </a:ext>
             </a:extLst>
           </a:blip>
@@ -4890,20 +4732,128 @@
         </p:blipFill>
         <p:spPr>
           <a:xfrm>
-            <a:off x="2604595" y="5685561"/>
-            <a:ext cx="776336" cy="776336"/>
+            <a:off x="5498894" y="3858654"/>
+            <a:ext cx="837978" cy="837978"/>
           </a:xfrm>
           <a:prstGeom prst="rect">
             <a:avLst/>
           </a:prstGeom>
         </p:spPr>
       </p:pic>
-      <p:sp>
-        <p:nvSpPr>
-          <p:cNvPr id="17" name="CaixaDeTexto 16">
-            <a:extLst>
-              <a:ext uri="{FF2B5EF4-FFF2-40B4-BE49-F238E27FC236}">
-                <a16:creationId xmlns:a16="http://schemas.microsoft.com/office/drawing/2014/main" id="{CD77491C-C18D-48E0-A3C9-CC924EEDD808}"/>
+      <p:pic>
+        <p:nvPicPr>
+          <p:cNvPr id="7" name="Gráfico 6">
+            <a:extLst>
+              <a:ext uri="{FF2B5EF4-FFF2-40B4-BE49-F238E27FC236}">
+                <a16:creationId xmlns:a16="http://schemas.microsoft.com/office/drawing/2014/main" id="{B08A1204-B49D-02FA-C3E6-2E2803ACE00D}"/>
+              </a:ext>
+            </a:extLst>
+          </p:cNvPr>
+          <p:cNvPicPr>
+            <a:picLocks noChangeAspect="1"/>
+          </p:cNvPicPr>
+          <p:nvPr/>
+        </p:nvPicPr>
+        <p:blipFill>
+          <a:blip r:embed="rId5">
+            <a:extLst>
+              <a:ext uri="{96DAC541-7B7A-43D3-8B79-37D633B846F1}">
+                <asvg:svgBlip xmlns:asvg="http://schemas.microsoft.com/office/drawing/2016/SVG/main" r:embed="rId6"/>
+              </a:ext>
+            </a:extLst>
+          </a:blip>
+          <a:stretch>
+            <a:fillRect/>
+          </a:stretch>
+        </p:blipFill>
+        <p:spPr>
+          <a:xfrm>
+            <a:off x="5568525" y="4736418"/>
+            <a:ext cx="698717" cy="698717"/>
+          </a:xfrm>
+          <a:prstGeom prst="rect">
+            <a:avLst/>
+          </a:prstGeom>
+        </p:spPr>
+      </p:pic>
+      <p:pic>
+        <p:nvPicPr>
+          <p:cNvPr id="22" name="Gráfico 21">
+            <a:extLst>
+              <a:ext uri="{FF2B5EF4-FFF2-40B4-BE49-F238E27FC236}">
+                <a16:creationId xmlns:a16="http://schemas.microsoft.com/office/drawing/2014/main" id="{081D1E47-67E6-B11A-6555-16172197F631}"/>
+              </a:ext>
+            </a:extLst>
+          </p:cNvPr>
+          <p:cNvPicPr>
+            <a:picLocks noChangeAspect="1"/>
+          </p:cNvPicPr>
+          <p:nvPr/>
+        </p:nvPicPr>
+        <p:blipFill>
+          <a:blip r:embed="rId7">
+            <a:extLst>
+              <a:ext uri="{96DAC541-7B7A-43D3-8B79-37D633B846F1}">
+                <asvg:svgBlip xmlns:asvg="http://schemas.microsoft.com/office/drawing/2016/SVG/main" r:embed="rId8"/>
+              </a:ext>
+            </a:extLst>
+          </a:blip>
+          <a:stretch>
+            <a:fillRect/>
+          </a:stretch>
+        </p:blipFill>
+        <p:spPr>
+          <a:xfrm>
+            <a:off x="788719" y="4706915"/>
+            <a:ext cx="698717" cy="698717"/>
+          </a:xfrm>
+          <a:prstGeom prst="rect">
+            <a:avLst/>
+          </a:prstGeom>
+        </p:spPr>
+      </p:pic>
+      <p:pic>
+        <p:nvPicPr>
+          <p:cNvPr id="24" name="Gráfico 23">
+            <a:extLst>
+              <a:ext uri="{FF2B5EF4-FFF2-40B4-BE49-F238E27FC236}">
+                <a16:creationId xmlns:a16="http://schemas.microsoft.com/office/drawing/2014/main" id="{BC825ADF-386E-7061-805B-115EF2DF5038}"/>
+              </a:ext>
+            </a:extLst>
+          </p:cNvPr>
+          <p:cNvPicPr>
+            <a:picLocks noChangeAspect="1"/>
+          </p:cNvPicPr>
+          <p:nvPr/>
+        </p:nvPicPr>
+        <p:blipFill>
+          <a:blip r:embed="rId9">
+            <a:extLst>
+              <a:ext uri="{96DAC541-7B7A-43D3-8B79-37D633B846F1}">
+                <asvg:svgBlip xmlns:asvg="http://schemas.microsoft.com/office/drawing/2016/SVG/main" r:embed="rId10"/>
+              </a:ext>
+            </a:extLst>
+          </a:blip>
+          <a:stretch>
+            <a:fillRect/>
+          </a:stretch>
+        </p:blipFill>
+        <p:spPr>
+          <a:xfrm>
+            <a:off x="719658" y="3858654"/>
+            <a:ext cx="767778" cy="767778"/>
+          </a:xfrm>
+          <a:prstGeom prst="rect">
+            <a:avLst/>
+          </a:prstGeom>
+        </p:spPr>
+      </p:pic>
+      <p:sp>
+        <p:nvSpPr>
+          <p:cNvPr id="27" name="CaixaDeTexto 26">
+            <a:extLst>
+              <a:ext uri="{FF2B5EF4-FFF2-40B4-BE49-F238E27FC236}">
+                <a16:creationId xmlns:a16="http://schemas.microsoft.com/office/drawing/2014/main" id="{3836882C-DD6B-486D-C4FE-4C2EC1D1ACD6}"/>
               </a:ext>
             </a:extLst>
           </p:cNvPr>
@@ -4912,8 +4862,8 @@
         </p:nvSpPr>
         <p:spPr>
           <a:xfrm>
-            <a:off x="3401321" y="5765591"/>
-            <a:ext cx="1593130" cy="369332"/>
+            <a:off x="1671765" y="4069040"/>
+            <a:ext cx="3626619" cy="461665"/>
           </a:xfrm>
           <a:prstGeom prst="rect">
             <a:avLst/>
@@ -4921,36 +4871,20 @@
           <a:noFill/>
         </p:spPr>
         <p:txBody>
-          <a:bodyPr wrap="square" lIns="91440" tIns="45720" rIns="91440" bIns="45720" rtlCol="0" anchor="t">
+          <a:bodyPr wrap="square">
             <a:spAutoFit/>
           </a:bodyPr>
           <a:lstStyle/>
           <a:p>
             <a:r>
-              <a:rPr lang="pt-BR" dirty="0" err="1">
+              <a:rPr lang="pt-BR" sz="2400" dirty="0">
                 <a:solidFill>
                   <a:schemeClr val="bg1"/>
                 </a:solidFill>
               </a:rPr>
-              <a:t>Regístree</a:t>
-            </a:r>
-            <a:r>
-              <a:rPr lang="pt-BR" dirty="0">
-                <a:solidFill>
-                  <a:schemeClr val="bg1"/>
-                </a:solidFill>
-              </a:rPr>
-              <a:t> </a:t>
-            </a:r>
-            <a:r>
-              <a:rPr lang="pt-BR" dirty="0" err="1">
-                <a:solidFill>
-                  <a:schemeClr val="bg1"/>
-                </a:solidFill>
-              </a:rPr>
-              <a:t>en</a:t>
-            </a:r>
-            <a:endParaRPr lang="en-US" dirty="0">
+              <a:t>20 de Fevereiro 2026</a:t>
+            </a:r>
+            <a:endParaRPr lang="en-US" sz="2400" dirty="0">
               <a:solidFill>
                 <a:schemeClr val="bg1"/>
               </a:solidFill>
@@ -4960,10 +4894,10 @@
       </p:sp>
       <p:sp>
         <p:nvSpPr>
-          <p:cNvPr id="25" name="CaixaDeTexto 24">
-            <a:extLst>
-              <a:ext uri="{FF2B5EF4-FFF2-40B4-BE49-F238E27FC236}">
-                <a16:creationId xmlns:a16="http://schemas.microsoft.com/office/drawing/2014/main" id="{DBE92BF6-08EE-3679-3DE0-7F4A3756D185}"/>
+          <p:cNvPr id="28" name="CaixaDeTexto 27">
+            <a:extLst>
+              <a:ext uri="{FF2B5EF4-FFF2-40B4-BE49-F238E27FC236}">
+                <a16:creationId xmlns:a16="http://schemas.microsoft.com/office/drawing/2014/main" id="{3E30F182-F207-8990-0532-8AC371476881}"/>
               </a:ext>
             </a:extLst>
           </p:cNvPr>
@@ -4972,8 +4906,8 @@
         </p:nvSpPr>
         <p:spPr>
           <a:xfrm>
-            <a:off x="3401321" y="6090894"/>
-            <a:ext cx="3523262" cy="369332"/>
+            <a:off x="1671765" y="4778265"/>
+            <a:ext cx="3626619" cy="461665"/>
           </a:xfrm>
           <a:prstGeom prst="rect">
             <a:avLst/>
@@ -4987,7 +4921,67 @@
           <a:lstStyle/>
           <a:p>
             <a:r>
+              <a:rPr lang="pt-BR" sz="2400" dirty="0">
+                <a:solidFill>
+                  <a:schemeClr val="bg1"/>
+                </a:solidFill>
+              </a:rPr>
+              <a:t>00pm </a:t>
+            </a:r>
+            <a:r>
               <a:rPr lang="pt-BR" dirty="0">
+                <a:solidFill>
+                  <a:schemeClr val="bg1"/>
+                </a:solidFill>
+              </a:rPr>
+              <a:t>(Brasília, GMT-3)</a:t>
+            </a:r>
+            <a:endParaRPr lang="en-US" dirty="0">
+              <a:solidFill>
+                <a:schemeClr val="bg1"/>
+              </a:solidFill>
+            </a:endParaRPr>
+          </a:p>
+        </p:txBody>
+      </p:sp>
+      <p:sp>
+        <p:nvSpPr>
+          <p:cNvPr id="29" name="CaixaDeTexto 28">
+            <a:extLst>
+              <a:ext uri="{FF2B5EF4-FFF2-40B4-BE49-F238E27FC236}">
+                <a16:creationId xmlns:a16="http://schemas.microsoft.com/office/drawing/2014/main" id="{89838DA7-5164-01CD-6D2F-F758E1A8FCC7}"/>
+              </a:ext>
+            </a:extLst>
+          </p:cNvPr>
+          <p:cNvSpPr txBox="1"/>
+          <p:nvPr/>
+        </p:nvSpPr>
+        <p:spPr>
+          <a:xfrm>
+            <a:off x="6537383" y="4069040"/>
+            <a:ext cx="3626619" cy="461665"/>
+          </a:xfrm>
+          <a:prstGeom prst="rect">
+            <a:avLst/>
+          </a:prstGeom>
+          <a:noFill/>
+        </p:spPr>
+        <p:txBody>
+          <a:bodyPr wrap="square">
+            <a:spAutoFit/>
+          </a:bodyPr>
+          <a:lstStyle/>
+          <a:p>
+            <a:r>
+              <a:rPr lang="pt-BR" sz="2400" dirty="0">
+                <a:solidFill>
+                  <a:schemeClr val="bg1"/>
+                </a:solidFill>
+              </a:rPr>
+              <a:t>Link: </a:t>
+            </a:r>
+            <a:r>
+              <a:rPr lang="pt-BR" sz="2400" dirty="0">
                 <a:solidFill>
                   <a:schemeClr val="bg1"/>
                 </a:solidFill>
@@ -4996,7 +4990,7 @@
               </a:rPr>
               <a:t>bit.ly/link</a:t>
             </a:r>
-            <a:endParaRPr lang="en-US" dirty="0">
+            <a:endParaRPr lang="en-US" sz="2400" dirty="0">
               <a:solidFill>
                 <a:schemeClr val="bg1"/>
               </a:solidFill>
@@ -5004,208 +4998,12 @@
           </a:p>
         </p:txBody>
       </p:sp>
-      <p:grpSp>
-        <p:nvGrpSpPr>
-          <p:cNvPr id="4" name="Agrupar 3">
-            <a:extLst>
-              <a:ext uri="{FF2B5EF4-FFF2-40B4-BE49-F238E27FC236}">
-                <a16:creationId xmlns:a16="http://schemas.microsoft.com/office/drawing/2014/main" id="{3C6ADD74-3731-5AE1-85FE-3686D37A0403}"/>
-              </a:ext>
-            </a:extLst>
-          </p:cNvPr>
-          <p:cNvGrpSpPr/>
-          <p:nvPr/>
-        </p:nvGrpSpPr>
-        <p:grpSpPr>
-          <a:xfrm>
-            <a:off x="7576988" y="1610444"/>
-            <a:ext cx="2505527" cy="1213926"/>
-            <a:chOff x="7013187" y="2368281"/>
-            <a:chExt cx="2939091" cy="1423987"/>
-          </a:xfrm>
-        </p:grpSpPr>
-        <p:cxnSp>
-          <p:nvCxnSpPr>
-            <p:cNvPr id="11" name="Conector reto 10">
-              <a:extLst>
-                <a:ext uri="{FF2B5EF4-FFF2-40B4-BE49-F238E27FC236}">
-                  <a16:creationId xmlns:a16="http://schemas.microsoft.com/office/drawing/2014/main" id="{C9C967F7-B710-AEA7-C8BF-CFB730C22A5F}"/>
-                </a:ext>
-              </a:extLst>
-            </p:cNvPr>
-            <p:cNvCxnSpPr/>
-            <p:nvPr/>
-          </p:nvCxnSpPr>
-          <p:spPr>
-            <a:xfrm>
-              <a:off x="8235397" y="3357273"/>
-              <a:ext cx="1716881" cy="0"/>
-            </a:xfrm>
-            <a:prstGeom prst="line">
-              <a:avLst/>
-            </a:prstGeom>
-            <a:ln>
-              <a:solidFill>
-                <a:schemeClr val="bg1"/>
-              </a:solidFill>
-            </a:ln>
-          </p:spPr>
-          <p:style>
-            <a:lnRef idx="1">
-              <a:schemeClr val="dk1"/>
-            </a:lnRef>
-            <a:fillRef idx="0">
-              <a:schemeClr val="dk1"/>
-            </a:fillRef>
-            <a:effectRef idx="0">
-              <a:schemeClr val="dk1"/>
-            </a:effectRef>
-            <a:fontRef idx="minor">
-              <a:schemeClr val="tx1"/>
-            </a:fontRef>
-          </p:style>
-        </p:cxnSp>
-        <p:sp>
-          <p:nvSpPr>
-            <p:cNvPr id="13" name="Elipse 12">
-              <a:extLst>
-                <a:ext uri="{FF2B5EF4-FFF2-40B4-BE49-F238E27FC236}">
-                  <a16:creationId xmlns:a16="http://schemas.microsoft.com/office/drawing/2014/main" id="{464124E6-57CF-452C-4ABA-86627D193CC2}"/>
-                </a:ext>
-              </a:extLst>
-            </p:cNvPr>
-            <p:cNvSpPr/>
-            <p:nvPr/>
-          </p:nvSpPr>
-          <p:spPr>
-            <a:xfrm>
-              <a:off x="7013187" y="2368281"/>
-              <a:ext cx="1423987" cy="1423987"/>
-            </a:xfrm>
-            <a:prstGeom prst="ellipse">
-              <a:avLst/>
-            </a:prstGeom>
-            <a:blipFill>
-              <a:blip r:embed="rId4">
-                <a:extLst>
-                  <a:ext uri="{28A0092B-C50C-407E-A947-70E740481C1C}">
-                    <a14:useLocalDpi xmlns:a14="http://schemas.microsoft.com/office/drawing/2010/main" val="0"/>
-                  </a:ext>
-                </a:extLst>
-              </a:blip>
-              <a:srcRect/>
-              <a:stretch>
-                <a:fillRect l="-25000" r="-25000"/>
-              </a:stretch>
-            </a:blipFill>
-            <a:ln>
-              <a:solidFill>
-                <a:schemeClr val="bg2"/>
-              </a:solidFill>
-            </a:ln>
-          </p:spPr>
-          <p:style>
-            <a:lnRef idx="2">
-              <a:schemeClr val="lt1">
-                <a:hueOff val="0"/>
-                <a:satOff val="0"/>
-                <a:lumOff val="0"/>
-                <a:alphaOff val="0"/>
-              </a:schemeClr>
-            </a:lnRef>
-            <a:fillRef idx="1">
-              <a:scrgbClr r="0" g="0" b="0"/>
-            </a:fillRef>
-            <a:effectRef idx="0">
-              <a:schemeClr val="accent1">
-                <a:tint val="50000"/>
-                <a:hueOff val="0"/>
-                <a:satOff val="0"/>
-                <a:lumOff val="0"/>
-                <a:alphaOff val="0"/>
-              </a:schemeClr>
-            </a:effectRef>
-            <a:fontRef idx="minor">
-              <a:schemeClr val="lt1">
-                <a:hueOff val="0"/>
-                <a:satOff val="0"/>
-                <a:lumOff val="0"/>
-                <a:alphaOff val="0"/>
-              </a:schemeClr>
-            </a:fontRef>
-          </p:style>
-          <p:txBody>
-            <a:bodyPr/>
-            <a:lstStyle/>
-            <a:p>
-              <a:endParaRPr lang="pt-BR" u="sng"/>
-            </a:p>
-          </p:txBody>
-        </p:sp>
-        <p:sp>
-          <p:nvSpPr>
-            <p:cNvPr id="16" name="CaixaDeTexto 15">
-              <a:extLst>
-                <a:ext uri="{FF2B5EF4-FFF2-40B4-BE49-F238E27FC236}">
-                  <a16:creationId xmlns:a16="http://schemas.microsoft.com/office/drawing/2014/main" id="{F18E2D07-1B96-A808-1625-0E215FBBF61C}"/>
-                </a:ext>
-              </a:extLst>
-            </p:cNvPr>
-            <p:cNvSpPr txBox="1"/>
-            <p:nvPr/>
-          </p:nvSpPr>
-          <p:spPr>
-            <a:xfrm>
-              <a:off x="8437174" y="2722541"/>
-              <a:ext cx="1324017" cy="553998"/>
-            </a:xfrm>
-            <a:prstGeom prst="rect">
-              <a:avLst/>
-            </a:prstGeom>
-            <a:noFill/>
-          </p:spPr>
-          <p:txBody>
-            <a:bodyPr wrap="square">
-              <a:spAutoFit/>
-            </a:bodyPr>
-            <a:lstStyle/>
-            <a:p>
-              <a:r>
-                <a:rPr lang="pt-BR" sz="1600" b="1" dirty="0">
-                  <a:solidFill>
-                    <a:srgbClr val="2BF6D1"/>
-                  </a:solidFill>
-                  <a:cs typeface="Calibri"/>
-                </a:rPr>
-                <a:t>NOME</a:t>
-              </a:r>
-              <a:endParaRPr lang="en-US" sz="1600" dirty="0">
-                <a:cs typeface="Calibri" panose="020F0502020204030204"/>
-              </a:endParaRPr>
-            </a:p>
-            <a:p>
-              <a:r>
-                <a:rPr lang="pt-BR" sz="1400" dirty="0">
-                  <a:solidFill>
-                    <a:schemeClr val="bg1">
-                      <a:lumMod val="95000"/>
-                    </a:schemeClr>
-                  </a:solidFill>
-                  <a:ea typeface="+mn-lt"/>
-                  <a:cs typeface="+mn-lt"/>
-                </a:rPr>
-                <a:t>Instituição</a:t>
-              </a:r>
-            </a:p>
-          </p:txBody>
-        </p:sp>
-      </p:grpSp>
-      <p:sp>
-        <p:nvSpPr>
-          <p:cNvPr id="22" name="CaixaDeTexto 21">
-            <a:extLst>
-              <a:ext uri="{FF2B5EF4-FFF2-40B4-BE49-F238E27FC236}">
-                <a16:creationId xmlns:a16="http://schemas.microsoft.com/office/drawing/2014/main" id="{FB6FE4C9-2F65-B6CB-FA77-379F4299801C}"/>
+      <p:sp>
+        <p:nvSpPr>
+          <p:cNvPr id="30" name="CaixaDeTexto 29">
+            <a:extLst>
+              <a:ext uri="{FF2B5EF4-FFF2-40B4-BE49-F238E27FC236}">
+                <a16:creationId xmlns:a16="http://schemas.microsoft.com/office/drawing/2014/main" id="{5DFFFE86-FA25-2D00-4DCA-E2FD6C6EEEB7}"/>
               </a:ext>
             </a:extLst>
           </p:cNvPr>
@@ -5214,8 +5012,8 @@
         </p:nvSpPr>
         <p:spPr>
           <a:xfrm>
-            <a:off x="617295" y="3728033"/>
-            <a:ext cx="6094520" cy="923330"/>
+            <a:off x="6537383" y="4808679"/>
+            <a:ext cx="3626619" cy="461665"/>
           </a:xfrm>
           <a:prstGeom prst="rect">
             <a:avLst/>
@@ -5229,360 +5027,21 @@
           <a:lstStyle/>
           <a:p>
             <a:r>
-              <a:rPr lang="pt-BR" b="1" dirty="0">
-                <a:solidFill>
-                  <a:srgbClr val="2BF6D1"/>
-                </a:solidFill>
-                <a:cs typeface="Calibri"/>
-              </a:rPr>
-              <a:t>NOME</a:t>
-            </a:r>
-            <a:endParaRPr lang="en-US" dirty="0">
-              <a:cs typeface="Calibri" panose="020F0502020204030204"/>
-            </a:endParaRPr>
-          </a:p>
-          <a:p>
-            <a:r>
-              <a:rPr lang="pt-BR" sz="1800" dirty="0">
-                <a:solidFill>
-                  <a:schemeClr val="bg1">
-                    <a:lumMod val="95000"/>
-                  </a:schemeClr>
-                </a:solidFill>
-                <a:ea typeface="+mn-lt"/>
-                <a:cs typeface="+mn-lt"/>
-              </a:rPr>
-              <a:t>Cargo</a:t>
-            </a:r>
-          </a:p>
-          <a:p>
-            <a:r>
-              <a:rPr lang="pt-BR" sz="1800" dirty="0">
-                <a:solidFill>
-                  <a:schemeClr val="bg1">
-                    <a:lumMod val="95000"/>
-                  </a:schemeClr>
-                </a:solidFill>
-                <a:ea typeface="+mn-lt"/>
-                <a:cs typeface="+mn-lt"/>
-              </a:rPr>
-              <a:t>BIREME/OPS/OMS</a:t>
-            </a:r>
-            <a:endParaRPr lang="pt-BR" dirty="0">
-              <a:solidFill>
-                <a:schemeClr val="bg1">
-                  <a:lumMod val="95000"/>
-                </a:schemeClr>
-              </a:solidFill>
-              <a:ea typeface="+mn-lt"/>
-              <a:cs typeface="+mn-lt"/>
-            </a:endParaRPr>
-          </a:p>
-        </p:txBody>
-      </p:sp>
-      <p:sp>
-        <p:nvSpPr>
-          <p:cNvPr id="21" name="CaixaDeTexto 20">
-            <a:extLst>
-              <a:ext uri="{FF2B5EF4-FFF2-40B4-BE49-F238E27FC236}">
-                <a16:creationId xmlns:a16="http://schemas.microsoft.com/office/drawing/2014/main" id="{9764A249-F0F1-D3E3-4FA7-21AE4372BC1D}"/>
-              </a:ext>
-            </a:extLst>
-          </p:cNvPr>
-          <p:cNvSpPr txBox="1"/>
-          <p:nvPr/>
-        </p:nvSpPr>
-        <p:spPr>
-          <a:xfrm>
-            <a:off x="617295" y="1170596"/>
-            <a:ext cx="6383869" cy="954107"/>
-          </a:xfrm>
-          <a:prstGeom prst="rect">
-            <a:avLst/>
-          </a:prstGeom>
-          <a:noFill/>
-        </p:spPr>
-        <p:txBody>
-          <a:bodyPr wrap="square">
-            <a:spAutoFit/>
-          </a:bodyPr>
-          <a:lstStyle/>
-          <a:p>
-            <a:r>
-              <a:rPr lang="pt-BR" sz="2800" b="1" i="0" dirty="0">
+              <a:rPr lang="pt-BR" sz="2400" dirty="0">
                 <a:solidFill>
                   <a:schemeClr val="bg1"/>
                 </a:solidFill>
-                <a:effectLst/>
-                <a:latin typeface="-apple-system"/>
               </a:rPr>
-              <a:t>Indexação de documentos segundo a Metodologia LILACS</a:t>
-            </a:r>
-            <a:endParaRPr lang="pt-BR" sz="2800" b="1" dirty="0">
+              <a:t>Português, Español</a:t>
+            </a:r>
+            <a:endParaRPr lang="en-US" sz="2400" dirty="0">
               <a:solidFill>
                 <a:schemeClr val="bg1"/>
               </a:solidFill>
-              <a:ea typeface="Calibri"/>
-              <a:cs typeface="Calibri"/>
             </a:endParaRPr>
           </a:p>
         </p:txBody>
       </p:sp>
-      <p:sp>
-        <p:nvSpPr>
-          <p:cNvPr id="23" name="CaixaDeTexto 22">
-            <a:extLst>
-              <a:ext uri="{FF2B5EF4-FFF2-40B4-BE49-F238E27FC236}">
-                <a16:creationId xmlns:a16="http://schemas.microsoft.com/office/drawing/2014/main" id="{953B15D9-65DE-D166-4521-7DB8D10B3B34}"/>
-              </a:ext>
-            </a:extLst>
-          </p:cNvPr>
-          <p:cNvSpPr txBox="1"/>
-          <p:nvPr/>
-        </p:nvSpPr>
-        <p:spPr>
-          <a:xfrm>
-            <a:off x="617295" y="562571"/>
-            <a:ext cx="3768274" cy="584775"/>
-          </a:xfrm>
-          <a:prstGeom prst="rect">
-            <a:avLst/>
-          </a:prstGeom>
-          <a:noFill/>
-        </p:spPr>
-        <p:txBody>
-          <a:bodyPr wrap="square">
-            <a:spAutoFit/>
-          </a:bodyPr>
-          <a:lstStyle/>
-          <a:p>
-            <a:r>
-              <a:rPr lang="es-ES" sz="1600" b="1" i="0" dirty="0">
-                <a:solidFill>
-                  <a:schemeClr val="bg1"/>
-                </a:solidFill>
-                <a:effectLst/>
-                <a:latin typeface="-apple-system"/>
-              </a:rPr>
-              <a:t>Fortalecimiento de las Redes de</a:t>
-            </a:r>
-          </a:p>
-          <a:p>
-            <a:r>
-              <a:rPr lang="es-ES" sz="1600" b="1" i="0" dirty="0">
-                <a:solidFill>
-                  <a:schemeClr val="bg1"/>
-                </a:solidFill>
-                <a:effectLst/>
-                <a:latin typeface="-apple-system"/>
-              </a:rPr>
-              <a:t>Información en Salud en AL&amp;C 2025</a:t>
-            </a:r>
-            <a:endParaRPr lang="pt-BR" sz="1600" b="1" i="0" dirty="0">
-              <a:solidFill>
-                <a:schemeClr val="bg1"/>
-              </a:solidFill>
-              <a:effectLst/>
-            </a:endParaRPr>
-          </a:p>
-        </p:txBody>
-      </p:sp>
-      <p:grpSp>
-        <p:nvGrpSpPr>
-          <p:cNvPr id="3" name="Agrupar 2">
-            <a:extLst>
-              <a:ext uri="{FF2B5EF4-FFF2-40B4-BE49-F238E27FC236}">
-                <a16:creationId xmlns:a16="http://schemas.microsoft.com/office/drawing/2014/main" id="{788D14A4-BEFC-3652-5CB7-2732F59AFE64}"/>
-              </a:ext>
-            </a:extLst>
-          </p:cNvPr>
-          <p:cNvGrpSpPr/>
-          <p:nvPr/>
-        </p:nvGrpSpPr>
-        <p:grpSpPr>
-          <a:xfrm>
-            <a:off x="6959923" y="2948139"/>
-            <a:ext cx="2505527" cy="1213926"/>
-            <a:chOff x="7013187" y="2368281"/>
-            <a:chExt cx="2939091" cy="1423987"/>
-          </a:xfrm>
-        </p:grpSpPr>
-        <p:cxnSp>
-          <p:nvCxnSpPr>
-            <p:cNvPr id="5" name="Conector reto 4">
-              <a:extLst>
-                <a:ext uri="{FF2B5EF4-FFF2-40B4-BE49-F238E27FC236}">
-                  <a16:creationId xmlns:a16="http://schemas.microsoft.com/office/drawing/2014/main" id="{C9EA327C-8A7A-2164-5B81-BF50E831070D}"/>
-                </a:ext>
-              </a:extLst>
-            </p:cNvPr>
-            <p:cNvCxnSpPr/>
-            <p:nvPr/>
-          </p:nvCxnSpPr>
-          <p:spPr>
-            <a:xfrm>
-              <a:off x="8235397" y="3357273"/>
-              <a:ext cx="1716881" cy="0"/>
-            </a:xfrm>
-            <a:prstGeom prst="line">
-              <a:avLst/>
-            </a:prstGeom>
-            <a:ln>
-              <a:solidFill>
-                <a:schemeClr val="bg1"/>
-              </a:solidFill>
-            </a:ln>
-          </p:spPr>
-          <p:style>
-            <a:lnRef idx="1">
-              <a:schemeClr val="dk1"/>
-            </a:lnRef>
-            <a:fillRef idx="0">
-              <a:schemeClr val="dk1"/>
-            </a:fillRef>
-            <a:effectRef idx="0">
-              <a:schemeClr val="dk1"/>
-            </a:effectRef>
-            <a:fontRef idx="minor">
-              <a:schemeClr val="tx1"/>
-            </a:fontRef>
-          </p:style>
-        </p:cxnSp>
-        <p:sp>
-          <p:nvSpPr>
-            <p:cNvPr id="15" name="Elipse 14">
-              <a:extLst>
-                <a:ext uri="{FF2B5EF4-FFF2-40B4-BE49-F238E27FC236}">
-                  <a16:creationId xmlns:a16="http://schemas.microsoft.com/office/drawing/2014/main" id="{2ED3279D-B4C4-AFCF-0B66-FD2C150881C0}"/>
-                </a:ext>
-              </a:extLst>
-            </p:cNvPr>
-            <p:cNvSpPr/>
-            <p:nvPr/>
-          </p:nvSpPr>
-          <p:spPr>
-            <a:xfrm>
-              <a:off x="7013187" y="2368281"/>
-              <a:ext cx="1423987" cy="1423987"/>
-            </a:xfrm>
-            <a:prstGeom prst="ellipse">
-              <a:avLst/>
-            </a:prstGeom>
-            <a:blipFill>
-              <a:blip r:embed="rId4">
-                <a:extLst>
-                  <a:ext uri="{28A0092B-C50C-407E-A947-70E740481C1C}">
-                    <a14:useLocalDpi xmlns:a14="http://schemas.microsoft.com/office/drawing/2010/main" val="0"/>
-                  </a:ext>
-                </a:extLst>
-              </a:blip>
-              <a:srcRect/>
-              <a:stretch>
-                <a:fillRect l="-25000" r="-25000"/>
-              </a:stretch>
-            </a:blipFill>
-            <a:ln>
-              <a:solidFill>
-                <a:schemeClr val="bg2"/>
-              </a:solidFill>
-            </a:ln>
-          </p:spPr>
-          <p:style>
-            <a:lnRef idx="2">
-              <a:schemeClr val="lt1">
-                <a:hueOff val="0"/>
-                <a:satOff val="0"/>
-                <a:lumOff val="0"/>
-                <a:alphaOff val="0"/>
-              </a:schemeClr>
-            </a:lnRef>
-            <a:fillRef idx="1">
-              <a:scrgbClr r="0" g="0" b="0"/>
-            </a:fillRef>
-            <a:effectRef idx="0">
-              <a:schemeClr val="accent1">
-                <a:tint val="50000"/>
-                <a:hueOff val="0"/>
-                <a:satOff val="0"/>
-                <a:lumOff val="0"/>
-                <a:alphaOff val="0"/>
-              </a:schemeClr>
-            </a:effectRef>
-            <a:fontRef idx="minor">
-              <a:schemeClr val="lt1">
-                <a:hueOff val="0"/>
-                <a:satOff val="0"/>
-                <a:lumOff val="0"/>
-                <a:alphaOff val="0"/>
-              </a:schemeClr>
-            </a:fontRef>
-          </p:style>
-          <p:txBody>
-            <a:bodyPr/>
-            <a:lstStyle/>
-            <a:p>
-              <a:endParaRPr lang="pt-BR" u="sng"/>
-            </a:p>
-          </p:txBody>
-        </p:sp>
-        <p:sp>
-          <p:nvSpPr>
-            <p:cNvPr id="18" name="CaixaDeTexto 17">
-              <a:extLst>
-                <a:ext uri="{FF2B5EF4-FFF2-40B4-BE49-F238E27FC236}">
-                  <a16:creationId xmlns:a16="http://schemas.microsoft.com/office/drawing/2014/main" id="{0C58B838-129E-620E-2834-5CB30AC1139C}"/>
-                </a:ext>
-              </a:extLst>
-            </p:cNvPr>
-            <p:cNvSpPr txBox="1"/>
-            <p:nvPr/>
-          </p:nvSpPr>
-          <p:spPr>
-            <a:xfrm>
-              <a:off x="8437174" y="2722541"/>
-              <a:ext cx="1324017" cy="553998"/>
-            </a:xfrm>
-            <a:prstGeom prst="rect">
-              <a:avLst/>
-            </a:prstGeom>
-            <a:noFill/>
-          </p:spPr>
-          <p:txBody>
-            <a:bodyPr wrap="square">
-              <a:spAutoFit/>
-            </a:bodyPr>
-            <a:lstStyle/>
-            <a:p>
-              <a:r>
-                <a:rPr lang="pt-BR" sz="1600" b="1" dirty="0">
-                  <a:solidFill>
-                    <a:srgbClr val="2BF6D1"/>
-                  </a:solidFill>
-                  <a:cs typeface="Calibri"/>
-                </a:rPr>
-                <a:t>NOME</a:t>
-              </a:r>
-              <a:endParaRPr lang="en-US" sz="1600" dirty="0">
-                <a:cs typeface="Calibri" panose="020F0502020204030204"/>
-              </a:endParaRPr>
-            </a:p>
-            <a:p>
-              <a:r>
-                <a:rPr lang="pt-BR" sz="1400" dirty="0">
-                  <a:solidFill>
-                    <a:schemeClr val="bg1">
-                      <a:lumMod val="95000"/>
-                    </a:schemeClr>
-                  </a:solidFill>
-                  <a:ea typeface="+mn-lt"/>
-                  <a:cs typeface="+mn-lt"/>
-                </a:rPr>
-                <a:t>Instituição</a:t>
-              </a:r>
-            </a:p>
-          </p:txBody>
-        </p:sp>
-      </p:grpSp>
     </p:spTree>
     <p:extLst>
       <p:ext uri="{BB962C8B-B14F-4D97-AF65-F5344CB8AC3E}">
@@ -5773,805 +5232,6 @@
     <p:extLst>
       <p:ext uri="{BB962C8B-B14F-4D97-AF65-F5344CB8AC3E}">
         <p14:creationId xmlns:p14="http://schemas.microsoft.com/office/powerpoint/2010/main" val="1478084968"/>
-      </p:ext>
-    </p:extLst>
-  </p:cSld>
-  <p:clrMapOvr>
-    <a:masterClrMapping/>
-  </p:clrMapOvr>
-</p:sld>
-</file>
-
-<file path=ppt/slides/slide3.xml><?xml version="1.0" encoding="utf-8"?>
-<p:sld xmlns:a="http://schemas.openxmlformats.org/drawingml/2006/main" xmlns:r="http://schemas.openxmlformats.org/officeDocument/2006/relationships" xmlns:p="http://schemas.openxmlformats.org/presentationml/2006/main">
-  <p:cSld>
-    <p:bg>
-      <p:bgPr>
-        <a:blipFill dpi="0" rotWithShape="1">
-          <a:blip r:embed="rId2">
-            <a:lum/>
-          </a:blip>
-          <a:srcRect/>
-          <a:stretch>
-            <a:fillRect/>
-          </a:stretch>
-        </a:blipFill>
-        <a:effectLst/>
-      </p:bgPr>
-    </p:bg>
-    <p:spTree>
-      <p:nvGrpSpPr>
-        <p:cNvPr id="1" name="">
-          <a:extLst>
-            <a:ext uri="{FF2B5EF4-FFF2-40B4-BE49-F238E27FC236}">
-              <a16:creationId xmlns:a16="http://schemas.microsoft.com/office/drawing/2014/main" id="{B0F6A50F-281B-791F-E9B8-C0651FC6124E}"/>
-            </a:ext>
-          </a:extLst>
-        </p:cNvPr>
-        <p:cNvGrpSpPr/>
-        <p:nvPr/>
-      </p:nvGrpSpPr>
-      <p:grpSpPr>
-        <a:xfrm>
-          <a:off x="0" y="0"/>
-          <a:ext cx="0" cy="0"/>
-          <a:chOff x="0" y="0"/>
-          <a:chExt cx="0" cy="0"/>
-        </a:xfrm>
-      </p:grpSpPr>
-      <p:sp>
-        <p:nvSpPr>
-          <p:cNvPr id="5" name="CaixaDeTexto 4">
-            <a:extLst>
-              <a:ext uri="{FF2B5EF4-FFF2-40B4-BE49-F238E27FC236}">
-                <a16:creationId xmlns:a16="http://schemas.microsoft.com/office/drawing/2014/main" id="{B847D575-22A3-1319-C1B6-47DCF33A18E3}"/>
-              </a:ext>
-            </a:extLst>
-          </p:cNvPr>
-          <p:cNvSpPr txBox="1"/>
-          <p:nvPr/>
-        </p:nvSpPr>
-        <p:spPr>
-          <a:xfrm>
-            <a:off x="617295" y="1170596"/>
-            <a:ext cx="6383869" cy="954107"/>
-          </a:xfrm>
-          <a:prstGeom prst="rect">
-            <a:avLst/>
-          </a:prstGeom>
-          <a:noFill/>
-        </p:spPr>
-        <p:txBody>
-          <a:bodyPr wrap="square">
-            <a:spAutoFit/>
-          </a:bodyPr>
-          <a:lstStyle/>
-          <a:p>
-            <a:r>
-              <a:rPr lang="pt-BR" sz="2800" b="1" i="0" dirty="0">
-                <a:solidFill>
-                  <a:schemeClr val="bg1"/>
-                </a:solidFill>
-                <a:effectLst/>
-                <a:latin typeface="-apple-system"/>
-              </a:rPr>
-              <a:t>Indexação de documentos segundo a Metodologia LILACS</a:t>
-            </a:r>
-            <a:endParaRPr lang="pt-BR" sz="2800" b="1" dirty="0">
-              <a:solidFill>
-                <a:schemeClr val="bg1"/>
-              </a:solidFill>
-              <a:ea typeface="Calibri"/>
-              <a:cs typeface="Calibri"/>
-            </a:endParaRPr>
-          </a:p>
-        </p:txBody>
-      </p:sp>
-      <p:sp>
-        <p:nvSpPr>
-          <p:cNvPr id="15" name="CaixaDeTexto 14">
-            <a:extLst>
-              <a:ext uri="{FF2B5EF4-FFF2-40B4-BE49-F238E27FC236}">
-                <a16:creationId xmlns:a16="http://schemas.microsoft.com/office/drawing/2014/main" id="{0C9B2DFB-5EFE-A62B-1EC4-6760C7EE9F85}"/>
-              </a:ext>
-            </a:extLst>
-          </p:cNvPr>
-          <p:cNvSpPr txBox="1"/>
-          <p:nvPr/>
-        </p:nvSpPr>
-        <p:spPr>
-          <a:xfrm>
-            <a:off x="617295" y="562571"/>
-            <a:ext cx="3768274" cy="584775"/>
-          </a:xfrm>
-          <a:prstGeom prst="rect">
-            <a:avLst/>
-          </a:prstGeom>
-          <a:noFill/>
-        </p:spPr>
-        <p:txBody>
-          <a:bodyPr wrap="square">
-            <a:spAutoFit/>
-          </a:bodyPr>
-          <a:lstStyle/>
-          <a:p>
-            <a:r>
-              <a:rPr lang="es-ES" sz="1600" b="1" i="0">
-                <a:solidFill>
-                  <a:schemeClr val="bg1"/>
-                </a:solidFill>
-                <a:effectLst/>
-                <a:latin typeface="-apple-system"/>
-              </a:rPr>
-              <a:t>Fortalecimiento de las Redes de</a:t>
-            </a:r>
-          </a:p>
-          <a:p>
-            <a:r>
-              <a:rPr lang="es-ES" sz="1600" b="1" i="0" dirty="0">
-                <a:solidFill>
-                  <a:schemeClr val="bg1"/>
-                </a:solidFill>
-                <a:effectLst/>
-                <a:latin typeface="-apple-system"/>
-              </a:rPr>
-              <a:t>Información en Salud en AL&amp;C 2025</a:t>
-            </a:r>
-            <a:endParaRPr lang="pt-BR" sz="1600" b="1" i="0" dirty="0">
-              <a:solidFill>
-                <a:schemeClr val="bg1"/>
-              </a:solidFill>
-              <a:effectLst/>
-            </a:endParaRPr>
-          </a:p>
-        </p:txBody>
-      </p:sp>
-      <p:graphicFrame>
-        <p:nvGraphicFramePr>
-          <p:cNvPr id="24" name="Tabela 23">
-            <a:extLst>
-              <a:ext uri="{FF2B5EF4-FFF2-40B4-BE49-F238E27FC236}">
-                <a16:creationId xmlns:a16="http://schemas.microsoft.com/office/drawing/2014/main" id="{1AB0C67A-1CFC-E849-8327-BC6A87723129}"/>
-              </a:ext>
-            </a:extLst>
-          </p:cNvPr>
-          <p:cNvGraphicFramePr>
-            <a:graphicFrameLocks noGrp="1"/>
-          </p:cNvGraphicFramePr>
-          <p:nvPr>
-            <p:extLst>
-              <p:ext uri="{D42A27DB-BD31-4B8C-83A1-F6EECF244321}">
-                <p14:modId xmlns:p14="http://schemas.microsoft.com/office/powerpoint/2010/main" val="3712675055"/>
-              </p:ext>
-            </p:extLst>
-          </p:nvPr>
-        </p:nvGraphicFramePr>
-        <p:xfrm>
-          <a:off x="722170" y="2408143"/>
-          <a:ext cx="10352230" cy="3346110"/>
-        </p:xfrm>
-        <a:graphic>
-          <a:graphicData uri="http://schemas.openxmlformats.org/drawingml/2006/table">
-            <a:tbl>
-              <a:tblPr firstRow="1" bandRow="1">
-                <a:tableStyleId>{7DF18680-E054-41AD-8BC1-D1AEF772440D}</a:tableStyleId>
-              </a:tblPr>
-              <a:tblGrid>
-                <a:gridCol w="5176115">
-                  <a:extLst>
-                    <a:ext uri="{9D8B030D-6E8A-4147-A177-3AD203B41FA5}">
-                      <a16:colId xmlns:a16="http://schemas.microsoft.com/office/drawing/2014/main" val="859848124"/>
-                    </a:ext>
-                  </a:extLst>
-                </a:gridCol>
-                <a:gridCol w="5176115">
-                  <a:extLst>
-                    <a:ext uri="{9D8B030D-6E8A-4147-A177-3AD203B41FA5}">
-                      <a16:colId xmlns:a16="http://schemas.microsoft.com/office/drawing/2014/main" val="4238113433"/>
-                    </a:ext>
-                  </a:extLst>
-                </a:gridCol>
-              </a:tblGrid>
-              <a:tr h="557685">
-                <a:tc>
-                  <a:txBody>
-                    <a:bodyPr/>
-                    <a:lstStyle/>
-                    <a:p>
-                      <a:pPr algn="ctr"/>
-                      <a:r>
-                        <a:rPr lang="pt-BR" dirty="0"/>
-                        <a:t>MÊS</a:t>
-                      </a:r>
-                    </a:p>
-                  </a:txBody>
-                  <a:tcPr anchor="ctr"/>
-                </a:tc>
-                <a:tc>
-                  <a:txBody>
-                    <a:bodyPr/>
-                    <a:lstStyle/>
-                    <a:p>
-                      <a:pPr algn="ctr"/>
-                      <a:r>
-                        <a:rPr lang="pt-BR" dirty="0"/>
-                        <a:t>Às quintas-feiras</a:t>
-                      </a:r>
-                    </a:p>
-                  </a:txBody>
-                  <a:tcPr anchor="ctr"/>
-                </a:tc>
-                <a:extLst>
-                  <a:ext uri="{0D108BD9-81ED-4DB2-BD59-A6C34878D82A}">
-                    <a16:rowId xmlns:a16="http://schemas.microsoft.com/office/drawing/2014/main" val="1133986674"/>
-                  </a:ext>
-                </a:extLst>
-              </a:tr>
-              <a:tr h="557685">
-                <a:tc>
-                  <a:txBody>
-                    <a:bodyPr/>
-                    <a:lstStyle/>
-                    <a:p>
-                      <a:pPr algn="ctr"/>
-                      <a:r>
-                        <a:rPr lang="pt-BR" dirty="0"/>
-                        <a:t>Abril</a:t>
-                      </a:r>
-                    </a:p>
-                  </a:txBody>
-                  <a:tcPr anchor="ctr"/>
-                </a:tc>
-                <a:tc>
-                  <a:txBody>
-                    <a:bodyPr/>
-                    <a:lstStyle/>
-                    <a:p>
-                      <a:pPr algn="ctr"/>
-                      <a:r>
-                        <a:rPr lang="pt-BR" dirty="0"/>
-                        <a:t>25</a:t>
-                      </a:r>
-                    </a:p>
-                  </a:txBody>
-                  <a:tcPr anchor="ctr"/>
-                </a:tc>
-                <a:extLst>
-                  <a:ext uri="{0D108BD9-81ED-4DB2-BD59-A6C34878D82A}">
-                    <a16:rowId xmlns:a16="http://schemas.microsoft.com/office/drawing/2014/main" val="848118311"/>
-                  </a:ext>
-                </a:extLst>
-              </a:tr>
-              <a:tr h="557685">
-                <a:tc>
-                  <a:txBody>
-                    <a:bodyPr/>
-                    <a:lstStyle/>
-                    <a:p>
-                      <a:pPr algn="ctr"/>
-                      <a:r>
-                        <a:rPr lang="pt-BR" dirty="0"/>
-                        <a:t>Junho</a:t>
-                      </a:r>
-                    </a:p>
-                  </a:txBody>
-                  <a:tcPr anchor="ctr"/>
-                </a:tc>
-                <a:tc>
-                  <a:txBody>
-                    <a:bodyPr/>
-                    <a:lstStyle/>
-                    <a:p>
-                      <a:pPr algn="ctr"/>
-                      <a:r>
-                        <a:rPr lang="pt-BR" dirty="0"/>
-                        <a:t>26</a:t>
-                      </a:r>
-                    </a:p>
-                  </a:txBody>
-                  <a:tcPr anchor="ctr"/>
-                </a:tc>
-                <a:extLst>
-                  <a:ext uri="{0D108BD9-81ED-4DB2-BD59-A6C34878D82A}">
-                    <a16:rowId xmlns:a16="http://schemas.microsoft.com/office/drawing/2014/main" val="1308520419"/>
-                  </a:ext>
-                </a:extLst>
-              </a:tr>
-              <a:tr h="557685">
-                <a:tc>
-                  <a:txBody>
-                    <a:bodyPr/>
-                    <a:lstStyle/>
-                    <a:p>
-                      <a:pPr algn="ctr"/>
-                      <a:r>
-                        <a:rPr lang="pt-BR" dirty="0"/>
-                        <a:t>Agosto</a:t>
-                      </a:r>
-                    </a:p>
-                  </a:txBody>
-                  <a:tcPr anchor="ctr"/>
-                </a:tc>
-                <a:tc>
-                  <a:txBody>
-                    <a:bodyPr/>
-                    <a:lstStyle/>
-                    <a:p>
-                      <a:pPr algn="ctr"/>
-                      <a:r>
-                        <a:rPr lang="pt-BR" dirty="0"/>
-                        <a:t>28</a:t>
-                      </a:r>
-                    </a:p>
-                  </a:txBody>
-                  <a:tcPr anchor="ctr"/>
-                </a:tc>
-                <a:extLst>
-                  <a:ext uri="{0D108BD9-81ED-4DB2-BD59-A6C34878D82A}">
-                    <a16:rowId xmlns:a16="http://schemas.microsoft.com/office/drawing/2014/main" val="2664393135"/>
-                  </a:ext>
-                </a:extLst>
-              </a:tr>
-              <a:tr h="557685">
-                <a:tc>
-                  <a:txBody>
-                    <a:bodyPr/>
-                    <a:lstStyle/>
-                    <a:p>
-                      <a:pPr algn="ctr"/>
-                      <a:r>
-                        <a:rPr lang="pt-BR" dirty="0"/>
-                        <a:t>Outubro</a:t>
-                      </a:r>
-                    </a:p>
-                  </a:txBody>
-                  <a:tcPr anchor="ctr"/>
-                </a:tc>
-                <a:tc>
-                  <a:txBody>
-                    <a:bodyPr/>
-                    <a:lstStyle/>
-                    <a:p>
-                      <a:pPr algn="ctr"/>
-                      <a:r>
-                        <a:rPr lang="pt-BR" dirty="0"/>
-                        <a:t>24</a:t>
-                      </a:r>
-                    </a:p>
-                  </a:txBody>
-                  <a:tcPr anchor="ctr"/>
-                </a:tc>
-                <a:extLst>
-                  <a:ext uri="{0D108BD9-81ED-4DB2-BD59-A6C34878D82A}">
-                    <a16:rowId xmlns:a16="http://schemas.microsoft.com/office/drawing/2014/main" val="3450871848"/>
-                  </a:ext>
-                </a:extLst>
-              </a:tr>
-              <a:tr h="557685">
-                <a:tc>
-                  <a:txBody>
-                    <a:bodyPr/>
-                    <a:lstStyle/>
-                    <a:p>
-                      <a:pPr algn="ctr"/>
-                      <a:r>
-                        <a:rPr lang="pt-BR" dirty="0"/>
-                        <a:t>Novembro</a:t>
-                      </a:r>
-                    </a:p>
-                  </a:txBody>
-                  <a:tcPr anchor="ctr"/>
-                </a:tc>
-                <a:tc>
-                  <a:txBody>
-                    <a:bodyPr/>
-                    <a:lstStyle/>
-                    <a:p>
-                      <a:pPr algn="ctr"/>
-                      <a:r>
-                        <a:rPr lang="pt-BR" dirty="0"/>
-                        <a:t>28</a:t>
-                      </a:r>
-                    </a:p>
-                  </a:txBody>
-                  <a:tcPr anchor="ctr"/>
-                </a:tc>
-                <a:extLst>
-                  <a:ext uri="{0D108BD9-81ED-4DB2-BD59-A6C34878D82A}">
-                    <a16:rowId xmlns:a16="http://schemas.microsoft.com/office/drawing/2014/main" val="1519739843"/>
-                  </a:ext>
-                </a:extLst>
-              </a:tr>
-            </a:tbl>
-          </a:graphicData>
-        </a:graphic>
-      </p:graphicFrame>
-    </p:spTree>
-    <p:extLst>
-      <p:ext uri="{BB962C8B-B14F-4D97-AF65-F5344CB8AC3E}">
-        <p14:creationId xmlns:p14="http://schemas.microsoft.com/office/powerpoint/2010/main" val="882779961"/>
-      </p:ext>
-    </p:extLst>
-  </p:cSld>
-  <p:clrMapOvr>
-    <a:masterClrMapping/>
-  </p:clrMapOvr>
-</p:sld>
-</file>
-
-<file path=ppt/slides/slide4.xml><?xml version="1.0" encoding="utf-8"?>
-<p:sld xmlns:a="http://schemas.openxmlformats.org/drawingml/2006/main" xmlns:r="http://schemas.openxmlformats.org/officeDocument/2006/relationships" xmlns:p="http://schemas.openxmlformats.org/presentationml/2006/main">
-  <p:cSld>
-    <p:spTree>
-      <p:nvGrpSpPr>
-        <p:cNvPr id="1" name="">
-          <a:extLst>
-            <a:ext uri="{FF2B5EF4-FFF2-40B4-BE49-F238E27FC236}">
-              <a16:creationId xmlns:a16="http://schemas.microsoft.com/office/drawing/2014/main" id="{B6E57A33-FDBD-0008-EE65-270320924422}"/>
-            </a:ext>
-          </a:extLst>
-        </p:cNvPr>
-        <p:cNvGrpSpPr/>
-        <p:nvPr/>
-      </p:nvGrpSpPr>
-      <p:grpSpPr>
-        <a:xfrm>
-          <a:off x="0" y="0"/>
-          <a:ext cx="0" cy="0"/>
-          <a:chOff x="0" y="0"/>
-          <a:chExt cx="0" cy="0"/>
-        </a:xfrm>
-      </p:grpSpPr>
-      <p:sp>
-        <p:nvSpPr>
-          <p:cNvPr id="5" name="CaixaDeTexto 4">
-            <a:extLst>
-              <a:ext uri="{FF2B5EF4-FFF2-40B4-BE49-F238E27FC236}">
-                <a16:creationId xmlns:a16="http://schemas.microsoft.com/office/drawing/2014/main" id="{E81898F5-C650-BC2C-5620-51EC66A8877A}"/>
-              </a:ext>
-            </a:extLst>
-          </p:cNvPr>
-          <p:cNvSpPr txBox="1"/>
-          <p:nvPr/>
-        </p:nvSpPr>
-        <p:spPr>
-          <a:xfrm>
-            <a:off x="617295" y="1170596"/>
-            <a:ext cx="6383869" cy="954107"/>
-          </a:xfrm>
-          <a:prstGeom prst="rect">
-            <a:avLst/>
-          </a:prstGeom>
-          <a:noFill/>
-        </p:spPr>
-        <p:txBody>
-          <a:bodyPr wrap="square">
-            <a:spAutoFit/>
-          </a:bodyPr>
-          <a:lstStyle/>
-          <a:p>
-            <a:r>
-              <a:rPr lang="pt-BR" sz="2800" b="1" i="0" dirty="0">
-                <a:effectLst/>
-                <a:latin typeface="-apple-system"/>
-              </a:rPr>
-              <a:t>Indexação de documentos segundo a Metodologia LILACS</a:t>
-            </a:r>
-            <a:endParaRPr lang="pt-BR" sz="2800" b="1" dirty="0">
-              <a:ea typeface="Calibri"/>
-              <a:cs typeface="Calibri"/>
-            </a:endParaRPr>
-          </a:p>
-        </p:txBody>
-      </p:sp>
-      <p:sp>
-        <p:nvSpPr>
-          <p:cNvPr id="15" name="CaixaDeTexto 14">
-            <a:extLst>
-              <a:ext uri="{FF2B5EF4-FFF2-40B4-BE49-F238E27FC236}">
-                <a16:creationId xmlns:a16="http://schemas.microsoft.com/office/drawing/2014/main" id="{DD942027-4F6A-3736-529D-724397D68F73}"/>
-              </a:ext>
-            </a:extLst>
-          </p:cNvPr>
-          <p:cNvSpPr txBox="1"/>
-          <p:nvPr/>
-        </p:nvSpPr>
-        <p:spPr>
-          <a:xfrm>
-            <a:off x="617295" y="562571"/>
-            <a:ext cx="3768274" cy="584775"/>
-          </a:xfrm>
-          <a:prstGeom prst="rect">
-            <a:avLst/>
-          </a:prstGeom>
-          <a:noFill/>
-        </p:spPr>
-        <p:txBody>
-          <a:bodyPr wrap="square">
-            <a:spAutoFit/>
-          </a:bodyPr>
-          <a:lstStyle/>
-          <a:p>
-            <a:r>
-              <a:rPr lang="pt-BR" sz="1600" b="1" i="0" dirty="0">
-                <a:effectLst/>
-                <a:latin typeface="-apple-system"/>
-              </a:rPr>
-              <a:t>Fortalecimento das Redes</a:t>
-            </a:r>
-          </a:p>
-          <a:p>
-            <a:r>
-              <a:rPr lang="pt-BR" sz="1600" b="1" i="0" dirty="0">
-                <a:effectLst/>
-                <a:latin typeface="-apple-system"/>
-              </a:rPr>
-              <a:t>de Informação em Saúde na AL&amp;C 2025</a:t>
-            </a:r>
-            <a:endParaRPr lang="pt-BR" sz="1600" b="1" i="0" dirty="0">
-              <a:effectLst/>
-            </a:endParaRPr>
-          </a:p>
-        </p:txBody>
-      </p:sp>
-      <p:graphicFrame>
-        <p:nvGraphicFramePr>
-          <p:cNvPr id="24" name="Tabela 23">
-            <a:extLst>
-              <a:ext uri="{FF2B5EF4-FFF2-40B4-BE49-F238E27FC236}">
-                <a16:creationId xmlns:a16="http://schemas.microsoft.com/office/drawing/2014/main" id="{70B61890-F789-885A-69DC-B8EE05F4EE4B}"/>
-              </a:ext>
-            </a:extLst>
-          </p:cNvPr>
-          <p:cNvGraphicFramePr>
-            <a:graphicFrameLocks noGrp="1"/>
-          </p:cNvGraphicFramePr>
-          <p:nvPr/>
-        </p:nvGraphicFramePr>
-        <p:xfrm>
-          <a:off x="722170" y="2408143"/>
-          <a:ext cx="10352230" cy="3346110"/>
-        </p:xfrm>
-        <a:graphic>
-          <a:graphicData uri="http://schemas.openxmlformats.org/drawingml/2006/table">
-            <a:tbl>
-              <a:tblPr firstRow="1" bandRow="1">
-                <a:tableStyleId>{7DF18680-E054-41AD-8BC1-D1AEF772440D}</a:tableStyleId>
-              </a:tblPr>
-              <a:tblGrid>
-                <a:gridCol w="5176115">
-                  <a:extLst>
-                    <a:ext uri="{9D8B030D-6E8A-4147-A177-3AD203B41FA5}">
-                      <a16:colId xmlns:a16="http://schemas.microsoft.com/office/drawing/2014/main" val="859848124"/>
-                    </a:ext>
-                  </a:extLst>
-                </a:gridCol>
-                <a:gridCol w="5176115">
-                  <a:extLst>
-                    <a:ext uri="{9D8B030D-6E8A-4147-A177-3AD203B41FA5}">
-                      <a16:colId xmlns:a16="http://schemas.microsoft.com/office/drawing/2014/main" val="4238113433"/>
-                    </a:ext>
-                  </a:extLst>
-                </a:gridCol>
-              </a:tblGrid>
-              <a:tr h="557685">
-                <a:tc>
-                  <a:txBody>
-                    <a:bodyPr/>
-                    <a:lstStyle/>
-                    <a:p>
-                      <a:pPr algn="ctr"/>
-                      <a:r>
-                        <a:rPr lang="pt-BR" dirty="0"/>
-                        <a:t>MÊS</a:t>
-                      </a:r>
-                    </a:p>
-                  </a:txBody>
-                  <a:tcPr anchor="ctr"/>
-                </a:tc>
-                <a:tc>
-                  <a:txBody>
-                    <a:bodyPr/>
-                    <a:lstStyle/>
-                    <a:p>
-                      <a:pPr algn="ctr"/>
-                      <a:r>
-                        <a:rPr lang="pt-BR" dirty="0"/>
-                        <a:t>Às quintas-feiras</a:t>
-                      </a:r>
-                    </a:p>
-                  </a:txBody>
-                  <a:tcPr anchor="ctr"/>
-                </a:tc>
-                <a:extLst>
-                  <a:ext uri="{0D108BD9-81ED-4DB2-BD59-A6C34878D82A}">
-                    <a16:rowId xmlns:a16="http://schemas.microsoft.com/office/drawing/2014/main" val="1133986674"/>
-                  </a:ext>
-                </a:extLst>
-              </a:tr>
-              <a:tr h="557685">
-                <a:tc>
-                  <a:txBody>
-                    <a:bodyPr/>
-                    <a:lstStyle/>
-                    <a:p>
-                      <a:pPr algn="ctr"/>
-                      <a:r>
-                        <a:rPr lang="pt-BR" dirty="0"/>
-                        <a:t>Abril</a:t>
-                      </a:r>
-                    </a:p>
-                  </a:txBody>
-                  <a:tcPr anchor="ctr"/>
-                </a:tc>
-                <a:tc>
-                  <a:txBody>
-                    <a:bodyPr/>
-                    <a:lstStyle/>
-                    <a:p>
-                      <a:pPr algn="ctr"/>
-                      <a:r>
-                        <a:rPr lang="pt-BR" dirty="0"/>
-                        <a:t>25</a:t>
-                      </a:r>
-                    </a:p>
-                  </a:txBody>
-                  <a:tcPr anchor="ctr"/>
-                </a:tc>
-                <a:extLst>
-                  <a:ext uri="{0D108BD9-81ED-4DB2-BD59-A6C34878D82A}">
-                    <a16:rowId xmlns:a16="http://schemas.microsoft.com/office/drawing/2014/main" val="848118311"/>
-                  </a:ext>
-                </a:extLst>
-              </a:tr>
-              <a:tr h="557685">
-                <a:tc>
-                  <a:txBody>
-                    <a:bodyPr/>
-                    <a:lstStyle/>
-                    <a:p>
-                      <a:pPr algn="ctr"/>
-                      <a:r>
-                        <a:rPr lang="pt-BR" dirty="0"/>
-                        <a:t>Junho</a:t>
-                      </a:r>
-                    </a:p>
-                  </a:txBody>
-                  <a:tcPr anchor="ctr"/>
-                </a:tc>
-                <a:tc>
-                  <a:txBody>
-                    <a:bodyPr/>
-                    <a:lstStyle/>
-                    <a:p>
-                      <a:pPr algn="ctr"/>
-                      <a:r>
-                        <a:rPr lang="pt-BR" dirty="0"/>
-                        <a:t>26</a:t>
-                      </a:r>
-                    </a:p>
-                  </a:txBody>
-                  <a:tcPr anchor="ctr"/>
-                </a:tc>
-                <a:extLst>
-                  <a:ext uri="{0D108BD9-81ED-4DB2-BD59-A6C34878D82A}">
-                    <a16:rowId xmlns:a16="http://schemas.microsoft.com/office/drawing/2014/main" val="1308520419"/>
-                  </a:ext>
-                </a:extLst>
-              </a:tr>
-              <a:tr h="557685">
-                <a:tc>
-                  <a:txBody>
-                    <a:bodyPr/>
-                    <a:lstStyle/>
-                    <a:p>
-                      <a:pPr algn="ctr"/>
-                      <a:r>
-                        <a:rPr lang="pt-BR" dirty="0"/>
-                        <a:t>Agosto</a:t>
-                      </a:r>
-                    </a:p>
-                  </a:txBody>
-                  <a:tcPr anchor="ctr"/>
-                </a:tc>
-                <a:tc>
-                  <a:txBody>
-                    <a:bodyPr/>
-                    <a:lstStyle/>
-                    <a:p>
-                      <a:pPr algn="ctr"/>
-                      <a:r>
-                        <a:rPr lang="pt-BR" dirty="0"/>
-                        <a:t>28</a:t>
-                      </a:r>
-                    </a:p>
-                  </a:txBody>
-                  <a:tcPr anchor="ctr"/>
-                </a:tc>
-                <a:extLst>
-                  <a:ext uri="{0D108BD9-81ED-4DB2-BD59-A6C34878D82A}">
-                    <a16:rowId xmlns:a16="http://schemas.microsoft.com/office/drawing/2014/main" val="2664393135"/>
-                  </a:ext>
-                </a:extLst>
-              </a:tr>
-              <a:tr h="557685">
-                <a:tc>
-                  <a:txBody>
-                    <a:bodyPr/>
-                    <a:lstStyle/>
-                    <a:p>
-                      <a:pPr algn="ctr"/>
-                      <a:r>
-                        <a:rPr lang="pt-BR" dirty="0"/>
-                        <a:t>Outubro</a:t>
-                      </a:r>
-                    </a:p>
-                  </a:txBody>
-                  <a:tcPr anchor="ctr"/>
-                </a:tc>
-                <a:tc>
-                  <a:txBody>
-                    <a:bodyPr/>
-                    <a:lstStyle/>
-                    <a:p>
-                      <a:pPr algn="ctr"/>
-                      <a:r>
-                        <a:rPr lang="pt-BR" dirty="0"/>
-                        <a:t>24</a:t>
-                      </a:r>
-                    </a:p>
-                  </a:txBody>
-                  <a:tcPr anchor="ctr"/>
-                </a:tc>
-                <a:extLst>
-                  <a:ext uri="{0D108BD9-81ED-4DB2-BD59-A6C34878D82A}">
-                    <a16:rowId xmlns:a16="http://schemas.microsoft.com/office/drawing/2014/main" val="3450871848"/>
-                  </a:ext>
-                </a:extLst>
-              </a:tr>
-              <a:tr h="557685">
-                <a:tc>
-                  <a:txBody>
-                    <a:bodyPr/>
-                    <a:lstStyle/>
-                    <a:p>
-                      <a:pPr algn="ctr"/>
-                      <a:r>
-                        <a:rPr lang="pt-BR" dirty="0"/>
-                        <a:t>Novembro</a:t>
-                      </a:r>
-                    </a:p>
-                  </a:txBody>
-                  <a:tcPr anchor="ctr"/>
-                </a:tc>
-                <a:tc>
-                  <a:txBody>
-                    <a:bodyPr/>
-                    <a:lstStyle/>
-                    <a:p>
-                      <a:pPr algn="ctr"/>
-                      <a:r>
-                        <a:rPr lang="pt-BR" dirty="0"/>
-                        <a:t>28</a:t>
-                      </a:r>
-                    </a:p>
-                  </a:txBody>
-                  <a:tcPr anchor="ctr"/>
-                </a:tc>
-                <a:extLst>
-                  <a:ext uri="{0D108BD9-81ED-4DB2-BD59-A6C34878D82A}">
-                    <a16:rowId xmlns:a16="http://schemas.microsoft.com/office/drawing/2014/main" val="1519739843"/>
-                  </a:ext>
-                </a:extLst>
-              </a:tr>
-            </a:tbl>
-          </a:graphicData>
-        </a:graphic>
-      </p:graphicFrame>
-    </p:spTree>
-    <p:extLst>
-      <p:ext uri="{BB962C8B-B14F-4D97-AF65-F5344CB8AC3E}">
-        <p14:creationId xmlns:p14="http://schemas.microsoft.com/office/powerpoint/2010/main" val="904150010"/>
       </p:ext>
     </p:extLst>
   </p:cSld>

</xml_diff>